<commit_message>
Add facilitation speaker notes to review/exam/capstone decks (W7-9, 16-19)
The 7 non-lecture decks (review, midterm, capstone, final) had no speaker notes.
Add facilitation notes — how to RUN each session: timing, running Jeopardy + the
mock CTF, proctoring + exam-version rotation, capstone studio flow + peer review,
and the final CTF tournament + graded demos (viva-style probe). Now all 19 decks
carry speaker notes.

Rebuilt week07-09/16-19.pptx (notes embedded, verified not rendered on slides).

Co-Authored-By: Claude Opus 4.8 <noreply@anthropic.com>
</commit_message>
<xml_diff>
--- a/slides/pptx/week07.pptx
+++ b/slides/pptx/week07.pptx
@@ -509,7 +509,7 @@
           <a:p>
             <a:r>
               <a:rPr lang="en-US" dirty="0"/>
-              <a:t/>
+              <a:t>Energy up — review week is a GAME, not a lecture. Set the frame: today's job is "zero surprises on exam day." ~5h block = cumulative quiz + Jeopardy + mock CTF + cheat sheet. ~2 min.</a:t>
             </a:r>
             <a:endParaRPr lang="en-US" dirty="0"/>
           </a:p>
@@ -597,7 +597,7 @@
           <a:p>
             <a:r>
               <a:rPr lang="en-US" dirty="0"/>
-              <a:t/>
+              <a:t>Roadmap, 1 min. Start the session with the cumulative review quiz (quiz1.md, 25 pts, 30 min) per the AGENDA, THEN the games. Tell them everything today mirrors the real exam.</a:t>
             </a:r>
             <a:endParaRPr lang="en-US" dirty="0"/>
           </a:p>
@@ -685,7 +685,7 @@
           <a:p>
             <a:r>
               <a:rPr lang="en-US" dirty="0"/>
-              <a:t/>
+              <a:t>Fast recap — cold-call one student per row to give the one-liner from memory. Don't lecture; it's retrieval practice. ~10 min.</a:t>
             </a:r>
             <a:endParaRPr lang="en-US" dirty="0"/>
           </a:p>
@@ -773,7 +773,7 @@
           <a:p>
             <a:r>
               <a:rPr lang="en-US" dirty="0"/>
-              <a:t/>
+              <a:t>Run by Houses/teams. Prep the board beforehand (6 categories × 5 values, questions seeded from the exam item bank). Rules: team picks, answers; wrong answer loses the points; end with a Final-Jeopardy wager. Keep it fast and loud. Award points into the CTFd/Houses board. ~60–75 min.</a:t>
             </a:r>
             <a:endParaRPr lang="en-US" dirty="0"/>
           </a:p>
@@ -861,7 +861,7 @@
           <a:p>
             <a:r>
               <a:rPr lang="en-US" dirty="0"/>
-              <a:t/>
+              <a:t>Run the EXACT Week 9 format/timing (see mock-ctf.md) so the real CTF feels familiar. Circulate; offer hints that cost points. The point is calibration: they should leave knowing what they can/can't do. ~90 min.</a:t>
             </a:r>
             <a:endParaRPr lang="en-US" dirty="0"/>
           </a:p>
@@ -949,7 +949,7 @@
           <a:p>
             <a:r>
               <a:rPr lang="en-US" dirty="0"/>
-              <a:t/>
+              <a:t>Spend real time here — these are the top exam point-losers every cohort. Ask the room which they're shaky on and drill those. ~8 min.</a:t>
             </a:r>
             <a:endParaRPr lang="en-US" dirty="0"/>
           </a:p>
@@ -1037,7 +1037,7 @@
           <a:p>
             <a:r>
               <a:rPr lang="en-US" dirty="0"/>
-              <a:t/>
+              <a:t>Making the cheat sheet IS the studying (generative learning). Decide + announce now whether it's allowed in the written exam.</a:t>
             </a:r>
             <a:endParaRPr lang="en-US" dirty="0"/>
           </a:p>
@@ -1125,7 +1125,7 @@
           <a:p>
             <a:r>
               <a:rPr lang="en-US" dirty="0"/>
-              <a:t/>
+              <a:t>Logistics: state exam dates, what to bring, room/VM readiness for W9. Reassure: today's mock = the real thing.</a:t>
             </a:r>
             <a:endParaRPr lang="en-US" dirty="0"/>
           </a:p>
@@ -4038,100 +4038,7 @@
       </p:graphicFrame>
       <p:sp>
         <p:nvSpPr>
-          <p:cNvPr id="7" name="Shape 3"/>
-          <p:cNvSpPr/>
-          <p:nvPr/>
-        </p:nvSpPr>
-        <p:spPr>
-          <a:xfrm>
-            <a:off x="457200" y="2569464"/>
-            <a:ext cx="8229600" cy="896112"/>
-          </a:xfrm>
-          <a:prstGeom prst="roundRect">
-            <a:avLst>
-              <a:gd name="adj" fmla="val 8163"/>
-            </a:avLst>
-          </a:prstGeom>
-          <a:solidFill>
-            <a:srgbClr val="F1F5F9"/>
-          </a:solidFill>
-          <a:ln/>
-          <a:effectLst>
-            <a:outerShdw sx="100000" sy="100000" kx="0" ky="0" algn="bl" rotWithShape="0" blurRad="76200" dist="25400" dir="5400000">
-              <a:srgbClr val="000000">
-                <a:alpha val="12000"/>
-              </a:srgbClr>
-            </a:outerShdw>
-          </a:effectLst>
-        </p:spPr>
-      </p:sp>
-      <p:sp>
-        <p:nvSpPr>
-          <p:cNvPr id="8" name="Text 4"/>
-          <p:cNvSpPr/>
-          <p:nvPr/>
-        </p:nvSpPr>
-        <p:spPr>
-          <a:xfrm>
-            <a:off x="731520" y="2679192"/>
-            <a:ext cx="7680960" cy="676656"/>
-          </a:xfrm>
-          <a:prstGeom prst="rect">
-            <a:avLst/>
-          </a:prstGeom>
-          <a:noFill/>
-          <a:ln/>
-        </p:spPr>
-        <p:txBody>
-          <a:bodyPr wrap="square" lIns="0" tIns="0" rIns="0" bIns="0" rtlCol="0" anchor="t"/>
-          <a:lstStyle/>
-          <a:p>
-            <a:pPr marL="342900" indent="-342900">
-              <a:spcAft>
-                <a:spcPts val="600"/>
-              </a:spcAft>
-              <a:buSzPct val="100000"/>
-              <a:buChar char="•"/>
-            </a:pPr>
-            <a:r>
-              <a:rPr lang="en-US" sz="1400" dirty="0">
-                <a:solidFill>
-                  <a:srgbClr val="1F2937"/>
-                </a:solidFill>
-                <a:latin typeface="Calibri" pitchFamily="34" charset="0"/>
-                <a:ea typeface="Calibri" pitchFamily="34" charset="-122"/>
-                <a:cs typeface="Calibri" pitchFamily="34" charset="-120"/>
-              </a:rPr>
-              <a:t>Teams pick; wrong answers lose points</a:t>
-            </a:r>
-            <a:endParaRPr lang="en-US" sz="1400" dirty="0"/>
-          </a:p>
-          <a:p>
-            <a:pPr marL="342900" indent="-342900">
-              <a:spcAft>
-                <a:spcPts val="600"/>
-              </a:spcAft>
-              <a:buSzPct val="100000"/>
-              <a:buChar char="•"/>
-            </a:pPr>
-            <a:r>
-              <a:rPr lang="en-US" sz="1400" dirty="0">
-                <a:solidFill>
-                  <a:srgbClr val="1F2937"/>
-                </a:solidFill>
-                <a:latin typeface="Calibri" pitchFamily="34" charset="0"/>
-                <a:ea typeface="Calibri" pitchFamily="34" charset="-122"/>
-                <a:cs typeface="Calibri" pitchFamily="34" charset="-120"/>
-              </a:rPr>
-              <a:t>Final wager round</a:t>
-            </a:r>
-            <a:endParaRPr lang="en-US" sz="1400" dirty="0"/>
-          </a:p>
-        </p:txBody>
-      </p:sp>
-      <p:sp>
-        <p:nvSpPr>
-          <p:cNvPr id="9" name="Text 5"/>
+          <p:cNvPr id="7" name="Text 3"/>
           <p:cNvSpPr/>
           <p:nvPr/>
         </p:nvSpPr>
@@ -4170,7 +4077,7 @@
       </p:sp>
       <p:pic>
         <p:nvPicPr>
-          <p:cNvPr id="10" name="Image 1" descr="/Users/pop7/Library/CloudStorage/OneDrive-MonsterConnectCo.,Ltd/Lecture/KOSEN69 - software-security/slides/pptx/assets/logo-small.png">    </p:cNvPr>
+          <p:cNvPr id="8" name="Image 1" descr="/Users/pop7/Library/CloudStorage/OneDrive-MonsterConnectCo.,Ltd/Lecture/KOSEN69 - software-security/slides/pptx/assets/logo-small.png">    </p:cNvPr>
           <p:cNvPicPr>
             <a:picLocks noChangeAspect="1"/>
           </p:cNvPicPr>

</xml_diff>